<commit_message>
Grade the portrait A+ to F and rebuild the quiz as a fifty-item inventory.
The Brief writes quantities as Romans and says what a Letter brain is. The test shuffles sides, scores ten aspects on their own, and keeps the Letter-brain mark separate from the seats.
</commit_message>
<xml_diff>
--- a/public/brief.pptx
+++ b/public/brief.pptx
@@ -19,9 +19,10 @@
     <p:sldId id="267" r:id="rId13"/>
     <p:sldId id="268" r:id="rId14"/>
     <p:sldId id="269" r:id="rId15"/>
+    <p:sldId id="270" r:id="rId16"/>
   </p:sldIdLst>
   <p:notesMasterIdLst>
-    <p:notesMasterId r:id="rId16"/>
+    <p:notesMasterId r:id="rId17"/>
   </p:notesMasterIdLst>
   <p:sldSz cx="12192000" cy="6858000"/>
   <p:notesSz cx="6858000" cy="12192000"/>
@@ -516,7 +517,7 @@
             <a:r>
               <a:rPr lang="en-US" dirty="0"/>
               <a:t>Open in full screen. The guest should see the slide, not your notes.
-Say the club name once. Then start teaching.</a:t>
+Say the club name once. Then start teaching the II ways of looking.</a:t>
             </a:r>
             <a:endParaRPr lang="en-US" dirty="0"/>
           </a:p>
@@ -604,8 +605,7 @@
           <a:p>
             <a:r>
               <a:rPr lang="en-US" dirty="0"/>
-              <a:t>A high fit can still be a trap. A hard weather can still be a life’s work.
-Name the pair. An unnamed comparison is a scoreboard.</a:t>
+              <a:t>If they want a III check, ask whether they will stand behind the whole thing, or file it and forget it.</a:t>
             </a:r>
             <a:endParaRPr lang="en-US" dirty="0"/>
           </a:p>
@@ -693,8 +693,7 @@
           <a:p>
             <a:r>
               <a:rPr lang="en-US" dirty="0"/>
-              <a:t>They may type an ordinary number once so we can translate it. The reading will not say that number back.
-Counting is allowed. Calling the count the person is the mistake.</a:t>
+              <a:t>Do not let them turn the pair into a verdict. The certificate names these II, and only these II.</a:t>
             </a:r>
             <a:endParaRPr lang="en-US" dirty="0"/>
           </a:p>
@@ -782,8 +781,7 @@
           <a:p>
             <a:r>
               <a:rPr lang="en-US" dirty="0"/>
-              <a:t>This is one slide on purpose. If they want the Greek warrant, send them to Why.
-Do not map a Latin house onto a Greek hour. That is how you lie with a smile.</a:t>
+              <a:t>If they want the walk of A through Z, send them to the amounts page. Do not teach arithmetic in this room.</a:t>
             </a:r>
             <a:endParaRPr lang="en-US" dirty="0"/>
           </a:p>
@@ -871,8 +869,8 @@
           <a:p>
             <a:r>
               <a:rPr lang="en-US" dirty="0"/>
-              <a:t>If you hear destiny, legal-name supremacy, or lucky totals coming out of your mouth, stop and read this slide again.
-The cheat sheet carries the same list. They do not have to memorize Why.</a:t>
+              <a:t>This is I slide on purpose. If they want the Greek warrant, send them to Why.
+Do not map a Latin house onto a Greek hour. That is how you lie with a smile.</a:t>
             </a:r>
             <a:endParaRPr lang="en-US" dirty="0"/>
           </a:p>
@@ -960,8 +958,7 @@
           <a:p>
             <a:r>
               <a:rPr lang="en-US" dirty="0"/>
-              <a:t>Your job is a clean reading and a clean exit. The site does the rest.
-Do not add a closing prophecy. Hand them the card.</a:t>
+              <a:t>Read the left column as a confession of how Numerology talks. Read the right column as how the club talks.</a:t>
             </a:r>
             <a:endParaRPr lang="en-US" dirty="0"/>
           </a:p>
@@ -985,6 +982,95 @@
             <a:fld id="{F7021451-1387-4CA6-816F-3879F97B5CBC}" type="slidenum">
               <a:rPr lang="en-US"/>
               <a:t>14</a:t>
+            </a:fld>
+            <a:endParaRPr lang="en-US"/>
+          </a:p>
+        </p:txBody>
+      </p:sp>
+    </p:spTree>
+    <p:extLst>
+      <p:ext uri="{BB962C8B-B14F-4D97-AF65-F5344CB8AC3E}">
+        <p14:creationId xmlns:p14="http://schemas.microsoft.com/office/powerpoint/2010/main" val="1024086991"/>
+      </p:ext>
+    </p:extLst>
+  </p:cSld>
+  <p:clrMapOvr>
+    <a:masterClrMapping/>
+  </p:clrMapOvr>
+</p:notes>
+</file>
+
+<file path=ppt/notesSlides/notesSlide15.xml><?xml version="1.0" encoding="utf-8"?>
+<p:notes xmlns:a="http://schemas.openxmlformats.org/drawingml/2006/main" xmlns:r="http://schemas.openxmlformats.org/officeDocument/2006/relationships" xmlns:p="http://schemas.openxmlformats.org/presentationml/2006/main">
+  <p:cSld>
+    <p:spTree>
+      <p:nvGrpSpPr>
+        <p:cNvPr id="1" name=""/>
+        <p:cNvGrpSpPr/>
+        <p:nvPr/>
+      </p:nvGrpSpPr>
+      <p:grpSpPr>
+        <a:xfrm>
+          <a:off x="0" y="0"/>
+          <a:ext cx="0" cy="0"/>
+          <a:chOff x="0" y="0"/>
+          <a:chExt cx="0" cy="0"/>
+        </a:xfrm>
+      </p:grpSpPr>
+      <p:sp>
+        <p:nvSpPr>
+          <p:cNvPr id="2" name="Slide Image Placeholder 1"/>
+          <p:cNvSpPr>
+            <a:spLocks noGrp="1" noRot="1" noChangeAspect="1"/>
+          </p:cNvSpPr>
+          <p:nvPr>
+            <p:ph type="sldImg"/>
+          </p:nvPr>
+        </p:nvSpPr>
+        <p:spPr/>
+      </p:sp>
+      <p:sp>
+        <p:nvSpPr>
+          <p:cNvPr id="3" name="Notes Placeholder 2"/>
+          <p:cNvSpPr>
+            <a:spLocks noGrp="1"/>
+          </p:cNvSpPr>
+          <p:nvPr>
+            <p:ph type="body" idx="1"/>
+          </p:nvPr>
+        </p:nvSpPr>
+        <p:spPr/>
+        <p:txBody>
+          <a:bodyPr/>
+          <a:lstStyle/>
+          <a:p>
+            <a:r>
+              <a:rPr lang="en-US" dirty="0"/>
+              <a:t>Your job is a clean reading and a clean exit. The site does the rest.
+Do not add a closing prophecy. Hand them the card.</a:t>
+            </a:r>
+            <a:endParaRPr lang="en-US" dirty="0"/>
+          </a:p>
+        </p:txBody>
+      </p:sp>
+      <p:sp>
+        <p:nvSpPr>
+          <p:cNvPr id="4" name="Slide Number Placeholder 3"/>
+          <p:cNvSpPr>
+            <a:spLocks noGrp="1"/>
+          </p:cNvSpPr>
+          <p:nvPr>
+            <p:ph type="sldNum" sz="quarter" idx="10"/>
+          </p:nvPr>
+        </p:nvSpPr>
+        <p:spPr/>
+        <p:txBody>
+          <a:bodyPr/>
+          <a:lstStyle/>
+          <a:p>
+            <a:fld id="{F7021451-1387-4CA6-816F-3879F97B5CBC}" type="slidenum">
+              <a:rPr lang="en-US"/>
+              <a:t>15</a:t>
             </a:fld>
             <a:endParaRPr lang="en-US"/>
           </a:p>
@@ -1049,7 +1135,7 @@
           <a:p>
             <a:r>
               <a:rPr lang="en-US" dirty="0"/>
-              <a:t>If they only remember three things, they are these: username, path, weather.
+              <a:t>If they only remember a handful of things, they are these: the username, the path, and the weather of the day.
 The Brief is public. Anyone may take it. The ethic is how they share afterward.</a:t>
             </a:r>
             <a:endParaRPr lang="en-US" dirty="0"/>
@@ -1138,8 +1224,8 @@
           <a:p>
             <a:r>
               <a:rPr lang="en-US" dirty="0"/>
-              <a:t>Do not mock anyone who used life-path numbers. They already asked the right first question.
-If someone says this is Numerology with extra steps, you missed this slide.</a:t>
+              <a:t>Stay on this slide until they can say the difference in their own words.
+If they leave thinking we hate measurement, you overplayed the right column. Measurement is a servant. The failure is making it the person.</a:t>
             </a:r>
             <a:endParaRPr lang="en-US" dirty="0"/>
           </a:p>
@@ -1227,8 +1313,8 @@
           <a:p>
             <a:r>
               <a:rPr lang="en-US" dirty="0"/>
-              <a:t>Say Master and Emissary once. Define them in the next breath as two ways of seeing.
-The rest of the hour is this circuit applied to a handle, a day, and a decision.</a:t>
+              <a:t>Do not mock anyone who used a life-path reading. They already asked the right first question.
+If someone says this is Numerology with extra steps, you missed the last step we throw out.</a:t>
             </a:r>
             <a:endParaRPr lang="en-US" dirty="0"/>
           </a:p>
@@ -1316,8 +1402,7 @@
           <a:p>
             <a:r>
               <a:rPr lang="en-US" dirty="0"/>
-              <a:t>One is A. Zero is the Fool, which means a blank, not a secret fate.
-If the handle starts with a digit, that digit becomes a letter and may name the role. Say that plainly if it comes up.</a:t>
+              <a:t>This is the slide you point at if they ask whether we are anti-math. We are anti-replacement.</a:t>
             </a:r>
             <a:endParaRPr lang="en-US" dirty="0"/>
           </a:p>
@@ -1405,8 +1490,8 @@
           <a:p>
             <a:r>
               <a:rPr lang="en-US" dirty="0"/>
-              <a:t>Role, then how, then where. If you scramble the order, you are hiding.
-Do not let them hunt for a fourth letter that “explains everything.” Three seats are the reading.</a:t>
+              <a:t>If the handle begins with something that is not a letter, say plainly that it becomes a letter and may name the role.
+Do not ask for a birthday. Do not ask for a legal name. Those are the record office’s materials, not ours.</a:t>
             </a:r>
             <a:endParaRPr lang="en-US" dirty="0"/>
           </a:p>
@@ -1494,9 +1579,8 @@
           <a:p>
             <a:r>
               <a:rPr lang="en-US" dirty="0"/>
-              <a:t>Do not improvise a soul. Read the three seats, then the invitation, then stop.
-The path title on the site is “The Lover of the Open Circle.” Say it only if they ask for the name of the path.
-If they want more, open the live reading at letterology.club with this same username.</a:t>
+              <a:t>Role, then how, then where. If you scramble the order, you are hiding.
+Do not let them hunt for a IV letter that explains everything. The path is the reading.</a:t>
             </a:r>
             <a:endParaRPr lang="en-US" dirty="0"/>
           </a:p>
@@ -1584,8 +1668,8 @@
           <a:p>
             <a:r>
               <a:rPr lang="en-US" dirty="0"/>
-              <a:t>Willingness means which letters run warm today, and which withdraw.
-If they ask whether a low day means they are unlucky, say no. It means keep the step small.</a:t>
+              <a:t>The path title on the site is “The Lover of the Open Circle.” Say it only if they ask for the name of the path.
+If they want more, open the live reading at letterology.club with this same username.</a:t>
             </a:r>
             <a:endParaRPr lang="en-US" dirty="0"/>
           </a:p>
@@ -1673,8 +1757,8 @@
           <a:p>
             <a:r>
               <a:rPr lang="en-US" dirty="0"/>
-              <a:t>The site can time the act. It cannot take the walk for them.
-If they want a third check, ask whether they will stand behind the whole thing, or file it as a score and forget it.</a:t>
+              <a:t>Willingness means which letters run warm today, and which withdraw.
+If they ask whether a hard day means they are unlucky, say no. It means keep the step small.</a:t>
             </a:r>
             <a:endParaRPr lang="en-US" dirty="0"/>
           </a:p>
@@ -2178,7 +2262,7 @@
               <a:buNone/>
             </a:pPr>
             <a:r>
-              <a:rPr lang="en-US" sz="1800" dirty="0">
+              <a:rPr lang="en-US" sz="2000" dirty="0">
                 <a:solidFill>
                   <a:srgbClr val="1C1712"/>
                 </a:solidFill>
@@ -2186,9 +2270,9 @@
                 <a:ea typeface="Georgia" pitchFamily="34" charset="-122"/>
                 <a:cs typeface="Georgia" pitchFamily="34" charset="-120"/>
               </a:rPr>
-              <a:t>This is a short brief for people who will share a reading.</a:t>
-            </a:r>
-            <a:endParaRPr lang="en-US" sz="1800" dirty="0"/>
+              <a:t>A training for people who will read a name in public, and then stop talking.</a:t>
+            </a:r>
+            <a:endParaRPr lang="en-US" sz="2000" dirty="0"/>
           </a:p>
           <a:p>
             <a:pPr indent="0" marL="0">
@@ -2198,7 +2282,7 @@
               <a:buNone/>
             </a:pPr>
             <a:r>
-              <a:rPr lang="en-US" sz="1800" dirty="0">
+              <a:rPr lang="en-US" sz="2000" dirty="0">
                 <a:solidFill>
                   <a:srgbClr val="1C1712"/>
                 </a:solidFill>
@@ -2206,9 +2290,9 @@
                 <a:ea typeface="Georgia" pitchFamily="34" charset="-122"/>
                 <a:cs typeface="Georgia" pitchFamily="34" charset="-120"/>
               </a:rPr>
-              <a:t>You will learn what we read, how a path is made, what luck is, and how to leave the room without preaching.</a:t>
-            </a:r>
-            <a:endParaRPr lang="en-US" sz="1800" dirty="0"/>
+              <a:t>You are here to learn a way of looking. When you leave this room you should be able to meet a username as a face, say what kind of path it is, notice whether today will have the move, and hand someone a portrait without turning it into a sermon.</a:t>
+            </a:r>
+            <a:endParaRPr lang="en-US" sz="2000" dirty="0"/>
           </a:p>
         </p:txBody>
       </p:sp>
@@ -2245,7 +2329,7 @@
                 <a:ea typeface="Georgia" pitchFamily="34" charset="-122"/>
                 <a:cs typeface="Georgia" pitchFamily="34" charset="-120"/>
               </a:rPr>
-              <a:t>CC33 · letterology.club  ·  1 / 14</a:t>
+              <a:t>CC33 · letterology.club  ·  I · XV</a:t>
             </a:r>
             <a:endParaRPr lang="en-US" sz="1100" dirty="0"/>
           </a:p>
@@ -2366,7 +2450,7 @@
                 <a:ea typeface="Georgia" pitchFamily="34" charset="-122"/>
                 <a:cs typeface="Georgia" pitchFamily="34" charset="-120"/>
               </a:rPr>
-              <a:t>TWO HANDLES</a:t>
+              <a:t>A DECISION</a:t>
             </a:r>
             <a:endParaRPr lang="en-US" sz="1200" dirty="0"/>
           </a:p>
@@ -2405,7 +2489,7 @@
                 <a:ea typeface="Georgia" pitchFamily="34" charset="-122"/>
                 <a:cs typeface="Georgia" pitchFamily="34" charset="-120"/>
               </a:rPr>
-              <a:t>A fit of materials, not a soulmate</a:t>
+              <a:t>Read the act the same way you read the name</a:t>
             </a:r>
             <a:endParaRPr lang="en-US" sz="3200" dirty="0"/>
           </a:p>
@@ -2439,7 +2523,7 @@
               <a:buNone/>
             </a:pPr>
             <a:r>
-              <a:rPr lang="en-US" sz="1800" dirty="0">
+              <a:rPr lang="en-US" sz="1600" dirty="0">
                 <a:solidFill>
                   <a:srgbClr val="1C1712"/>
                 </a:solidFill>
@@ -2447,9 +2531,9 @@
                 <a:ea typeface="Georgia" pitchFamily="34" charset="-122"/>
                 <a:cs typeface="Georgia" pitchFamily="34" charset="-120"/>
               </a:rPr>
-              <a:t>We compare roles, methods, places, shared letters, and help one name already carries that the other is missing.</a:t>
-            </a:r>
-            <a:endParaRPr lang="en-US" sz="1800" dirty="0"/>
+              <a:t>A decision is also a name. Quit, ask them, ship the launch, stay: those are letters too, and they enter a room the same way a username does.</a:t>
+            </a:r>
+            <a:endParaRPr lang="en-US" sz="1600" dirty="0"/>
           </a:p>
           <a:p>
             <a:pPr indent="0" marL="0">
@@ -2459,7 +2543,7 @@
               <a:buNone/>
             </a:pPr>
             <a:r>
-              <a:rPr lang="en-US" sz="1800" dirty="0">
+              <a:rPr lang="en-US" sz="1600" dirty="0">
                 <a:solidFill>
                   <a:srgbClr val="1C1712"/>
                 </a:solidFill>
@@ -2467,29 +2551,9 @@
                 <a:ea typeface="Georgia" pitchFamily="34" charset="-122"/>
                 <a:cs typeface="Georgia" pitchFamily="34" charset="-120"/>
               </a:rPr>
-              <a:t>The number is a fit of materials.</a:t>
-            </a:r>
-            <a:endParaRPr lang="en-US" sz="1800" dirty="0"/>
-          </a:p>
-          <a:p>
-            <a:pPr indent="0" marL="0">
-              <a:spcAft>
-                <a:spcPts val="1000"/>
-              </a:spcAft>
-              <a:buNone/>
-            </a:pPr>
-            <a:r>
-              <a:rPr lang="en-US" sz="1800" dirty="0">
-                <a:solidFill>
-                  <a:srgbClr val="1C1712"/>
-                </a:solidFill>
-                <a:latin typeface="Georgia" pitchFamily="34" charset="0"/>
-                <a:ea typeface="Georgia" pitchFamily="34" charset="-122"/>
-                <a:cs typeface="Georgia" pitchFamily="34" charset="-120"/>
-              </a:rPr>
-              <a:t>It is not a forecast, and it is not a reason to stay or leave.</a:t>
-            </a:r>
-            <a:endParaRPr lang="en-US" sz="1800" dirty="0"/>
+              <a:t>Ask II questions only. Is this my kind of move? Is that house willing today? Then you still walk out the door. The site can time the act. It cannot take the walk for you.</a:t>
+            </a:r>
+            <a:endParaRPr lang="en-US" sz="1600" dirty="0"/>
           </a:p>
         </p:txBody>
       </p:sp>
@@ -2526,7 +2590,7 @@
                 <a:ea typeface="Georgia" pitchFamily="34" charset="-122"/>
                 <a:cs typeface="Georgia" pitchFamily="34" charset="-120"/>
               </a:rPr>
-              <a:t>CC33 · letterology.club  ·  10 / 14</a:t>
+              <a:t>CC33 · letterology.club  ·  X · XV</a:t>
             </a:r>
             <a:endParaRPr lang="en-US" sz="1100" dirty="0"/>
           </a:p>
@@ -2647,7 +2711,7 @@
                 <a:ea typeface="Georgia" pitchFamily="34" charset="-122"/>
                 <a:cs typeface="Georgia" pitchFamily="34" charset="-120"/>
               </a:rPr>
-              <a:t>THE COUNT</a:t>
+              <a:t>A PAIR OF NAMES</a:t>
             </a:r>
             <a:endParaRPr lang="en-US" sz="1200" dirty="0"/>
           </a:p>
@@ -2686,7 +2750,7 @@
                 <a:ea typeface="Georgia" pitchFamily="34" charset="-122"/>
                 <a:cs typeface="Georgia" pitchFamily="34" charset="-120"/>
               </a:rPr>
-              <a:t>Write amounts as letters</a:t>
+              <a:t>A fit of materials, not a soulmate</a:t>
             </a:r>
             <a:endParaRPr lang="en-US" sz="3200" dirty="0"/>
           </a:p>
@@ -2720,7 +2784,7 @@
               <a:buNone/>
             </a:pPr>
             <a:r>
-              <a:rPr lang="en-US" sz="1800" dirty="0">
+              <a:rPr lang="en-US" sz="1600" dirty="0">
                 <a:solidFill>
                   <a:srgbClr val="1C1712"/>
                 </a:solidFill>
@@ -2728,9 +2792,9 @@
                 <a:ea typeface="Georgia" pitchFamily="34" charset="-122"/>
                 <a:cs typeface="Georgia" pitchFamily="34" charset="-120"/>
               </a:rPr>
-              <a:t>A number is a compression of rank, year, price, or quantity.</a:t>
-            </a:r>
-            <a:endParaRPr lang="en-US" sz="1800" dirty="0"/>
+              <a:t>We look at how II usernames meet: their roles, their ways of working, the letters they share, and the help one already carries that the other is missing.</a:t>
+            </a:r>
+            <a:endParaRPr lang="en-US" sz="1600" dirty="0"/>
           </a:p>
           <a:p>
             <a:pPr indent="0" marL="0">
@@ -2740,7 +2804,7 @@
               <a:buNone/>
             </a:pPr>
             <a:r>
-              <a:rPr lang="en-US" sz="1800" dirty="0">
+              <a:rPr lang="en-US" sz="1600" dirty="0">
                 <a:solidFill>
                   <a:srgbClr val="1C1712"/>
                 </a:solidFill>
@@ -2748,49 +2812,9 @@
                 <a:ea typeface="Georgia" pitchFamily="34" charset="-122"/>
                 <a:cs typeface="Georgia" pitchFamily="34" charset="-120"/>
               </a:rPr>
-              <a:t>We write it as letters so it can live in the same system as a name.</a:t>
-            </a:r>
-            <a:endParaRPr lang="en-US" sz="1800" dirty="0"/>
-          </a:p>
-          <a:p>
-            <a:pPr indent="0" marL="0">
-              <a:spcAft>
-                <a:spcPts val="1000"/>
-              </a:spcAft>
-              <a:buNone/>
-            </a:pPr>
-            <a:r>
-              <a:rPr lang="en-US" sz="1800" dirty="0">
-                <a:solidFill>
-                  <a:srgbClr val="1C1712"/>
-                </a:solidFill>
-                <a:latin typeface="Georgia" pitchFamily="34" charset="0"/>
-                <a:ea typeface="Georgia" pitchFamily="34" charset="-122"/>
-                <a:cs typeface="Georgia" pitchFamily="34" charset="-120"/>
-              </a:rPr>
-              <a:t>A is one. Z is twenty-six. AA is twenty-seven.</a:t>
-            </a:r>
-            <a:endParaRPr lang="en-US" sz="1800" dirty="0"/>
-          </a:p>
-          <a:p>
-            <a:pPr indent="0" marL="0">
-              <a:spcAft>
-                <a:spcPts val="1000"/>
-              </a:spcAft>
-              <a:buNone/>
-            </a:pPr>
-            <a:r>
-              <a:rPr lang="en-US" sz="1800" dirty="0">
-                <a:solidFill>
-                  <a:srgbClr val="1C1712"/>
-                </a:solidFill>
-                <a:latin typeface="Georgia" pitchFamily="34" charset="0"/>
-                <a:ea typeface="Georgia" pitchFamily="34" charset="-122"/>
-                <a:cs typeface="Georgia" pitchFamily="34" charset="-120"/>
-              </a:rPr>
-              <a:t>We do not wrap J back into A. Zero is a blank, which we call the Fool.</a:t>
-            </a:r>
-            <a:endParaRPr lang="en-US" sz="1800" dirty="0"/>
+              <a:t>That meeting is a fit of materials. It is not a forecast, and it is not a reason to stay or leave. A close fit can still be a trap. A hard weather can still be a life’s work. Name the pair. An unnamed comparison is how you hide an argument.</a:t>
+            </a:r>
+            <a:endParaRPr lang="en-US" sz="1600" dirty="0"/>
           </a:p>
         </p:txBody>
       </p:sp>
@@ -2827,7 +2851,7 @@
                 <a:ea typeface="Georgia" pitchFamily="34" charset="-122"/>
                 <a:cs typeface="Georgia" pitchFamily="34" charset="-120"/>
               </a:rPr>
-              <a:t>CC33 · letterology.club  ·  11 / 14</a:t>
+              <a:t>CC33 · letterology.club  ·  XI · XV</a:t>
             </a:r>
             <a:endParaRPr lang="en-US" sz="1100" dirty="0"/>
           </a:p>
@@ -2948,7 +2972,7 @@
                 <a:ea typeface="Georgia" pitchFamily="34" charset="-122"/>
                 <a:cs typeface="Georgia" pitchFamily="34" charset="-120"/>
               </a:rPr>
-              <a:t>THE SECOND TONGUE</a:t>
+              <a:t>AMOUNTS</a:t>
             </a:r>
             <a:endParaRPr lang="en-US" sz="1200" dirty="0"/>
           </a:p>
@@ -2987,7 +3011,7 @@
                 <a:ea typeface="Georgia" pitchFamily="34" charset="-122"/>
                 <a:cs typeface="Georgia" pitchFamily="34" charset="-120"/>
               </a:rPr>
-              <a:t>Greek is not Latin in other clothes</a:t>
+              <a:t>A year has to live in the same house as a name</a:t>
             </a:r>
             <a:endParaRPr lang="en-US" sz="3200" dirty="0"/>
           </a:p>
@@ -3021,7 +3045,7 @@
               <a:buNone/>
             </a:pPr>
             <a:r>
-              <a:rPr lang="en-US" sz="1800" dirty="0">
+              <a:rPr lang="en-US" sz="1600" dirty="0">
                 <a:solidFill>
                   <a:srgbClr val="1C1712"/>
                 </a:solidFill>
@@ -3029,9 +3053,9 @@
                 <a:ea typeface="Georgia" pitchFamily="34" charset="-122"/>
                 <a:cs typeface="Georgia" pitchFamily="34" charset="-120"/>
               </a:rPr>
-              <a:t>First and last letters are the road: how the name enters, and how it finishes.</a:t>
-            </a:r>
-            <a:endParaRPr lang="en-US" sz="1800" dirty="0"/>
+              <a:t>When a year or a price arrives, it claims to be neutral. It is still only a compression of a life: rank, date, money, a way of reaching a body.</a:t>
+            </a:r>
+            <a:endParaRPr lang="en-US" sz="1600" dirty="0"/>
           </a:p>
           <a:p>
             <a:pPr indent="0" marL="0">
@@ -3041,7 +3065,7 @@
               <a:buNone/>
             </a:pPr>
             <a:r>
-              <a:rPr lang="en-US" sz="1800" dirty="0">
+              <a:rPr lang="en-US" sz="1600" dirty="0">
                 <a:solidFill>
                   <a:srgbClr val="1C1712"/>
                 </a:solidFill>
@@ -3049,49 +3073,9 @@
                 <a:ea typeface="Georgia" pitchFamily="34" charset="-122"/>
                 <a:cs typeface="Georgia" pitchFamily="34" charset="-120"/>
               </a:rPr>
-              <a:t>Vowels are sung in order. They are not weighed as a tally.</a:t>
-            </a:r>
-            <a:endParaRPr lang="en-US" sz="1800" dirty="0"/>
-          </a:p>
-          <a:p>
-            <a:pPr indent="0" marL="0">
-              <a:spcAft>
-                <a:spcPts val="1000"/>
-              </a:spcAft>
-              <a:buNone/>
-            </a:pPr>
-            <a:r>
-              <a:rPr lang="en-US" sz="1800" dirty="0">
-                <a:solidFill>
-                  <a:srgbClr val="1C1712"/>
-                </a:solidFill>
-                <a:latin typeface="Georgia" pitchFamily="34" charset="0"/>
-                <a:ea typeface="Georgia" pitchFamily="34" charset="-122"/>
-                <a:cs typeface="Georgia" pitchFamily="34" charset="-120"/>
-              </a:rPr>
-              <a:t>The sum lands on an hour, not a lucky digit. A sum is something the name can carry. It is not the name.</a:t>
-            </a:r>
-            <a:endParaRPr lang="en-US" sz="1800" dirty="0"/>
-          </a:p>
-          <a:p>
-            <a:pPr indent="0" marL="0">
-              <a:spcAft>
-                <a:spcPts val="1000"/>
-              </a:spcAft>
-              <a:buNone/>
-            </a:pPr>
-            <a:r>
-              <a:rPr lang="en-US" sz="1800" dirty="0">
-                <a:solidFill>
-                  <a:srgbClr val="1C1712"/>
-                </a:solidFill>
-                <a:latin typeface="Georgia" pitchFamily="34" charset="0"/>
-                <a:ea typeface="Georgia" pitchFamily="34" charset="-122"/>
-                <a:cs typeface="Georgia" pitchFamily="34" charset="-120"/>
-              </a:rPr>
-              <a:t>Flip the tongue when you want that instrument. Do not translate one into the other in the room.</a:t>
-            </a:r>
-            <a:endParaRPr lang="en-US" sz="1800" dirty="0"/>
+              <a:t>We write it in letters so it has to live in the same house as a name, instead of sitting apart as a rival religion. The blank is the Fool: nothing written, not a secret fate. You may type the old figure once so we can translate it. The reading will not say it back.</a:t>
+            </a:r>
+            <a:endParaRPr lang="en-US" sz="1600" dirty="0"/>
           </a:p>
         </p:txBody>
       </p:sp>
@@ -3128,7 +3112,7 @@
                 <a:ea typeface="Georgia" pitchFamily="34" charset="-122"/>
                 <a:cs typeface="Georgia" pitchFamily="34" charset="-120"/>
               </a:rPr>
-              <a:t>CC33 · letterology.club  ·  12 / 14</a:t>
+              <a:t>CC33 · letterology.club  ·  XII · XV</a:t>
             </a:r>
             <a:endParaRPr lang="en-US" sz="1100" dirty="0"/>
           </a:p>
@@ -3249,7 +3233,7 @@
                 <a:ea typeface="Georgia" pitchFamily="34" charset="-122"/>
                 <a:cs typeface="Georgia" pitchFamily="34" charset="-120"/>
               </a:rPr>
-              <a:t>SPEECH</a:t>
+              <a:t>TONGUE II</a:t>
             </a:r>
             <a:endParaRPr lang="en-US" sz="1200" dirty="0"/>
           </a:p>
@@ -3288,7 +3272,7 @@
                 <a:ea typeface="Georgia" pitchFamily="34" charset="-122"/>
                 <a:cs typeface="Georgia" pitchFamily="34" charset="-120"/>
               </a:rPr>
-              <a:t>Never say / say this</a:t>
+              <a:t>Greek is not Latin in other clothes</a:t>
             </a:r>
             <a:endParaRPr lang="en-US" sz="3200" dirty="0"/>
           </a:p>
@@ -3322,7 +3306,7 @@
               <a:buNone/>
             </a:pPr>
             <a:r>
-              <a:rPr lang="en-US" sz="1800" dirty="0">
+              <a:rPr lang="en-US" sz="1600" dirty="0">
                 <a:solidFill>
                   <a:srgbClr val="1C1712"/>
                 </a:solidFill>
@@ -3330,9 +3314,9 @@
                 <a:ea typeface="Georgia" pitchFamily="34" charset="-122"/>
                 <a:cs typeface="Georgia" pitchFamily="34" charset="-120"/>
               </a:rPr>
-              <a:t>Never say: This is your destiny. The legal name is the real one. High fit means stay. A low day means you are unlucky. The total is a lucky number. Greek is Latin in other clothes.</a:t>
-            </a:r>
-            <a:endParaRPr lang="en-US" sz="1800" dirty="0"/>
+              <a:t>First and last letters are the road: how the name enters, and how it finishes. Vowels are sung in order; they are not piled as a clerk would pile them. Whatever the name can carry is an hour it leans toward, not a lucky stand-in for the person.</a:t>
+            </a:r>
+            <a:endParaRPr lang="en-US" sz="1600" dirty="0"/>
           </a:p>
           <a:p>
             <a:pPr indent="0" marL="0">
@@ -3342,7 +3326,7 @@
               <a:buNone/>
             </a:pPr>
             <a:r>
-              <a:rPr lang="en-US" sz="1800" dirty="0">
+              <a:rPr lang="en-US" sz="1600" dirty="0">
                 <a:solidFill>
                   <a:srgbClr val="1C1712"/>
                 </a:solidFill>
@@ -3350,9 +3334,9 @@
                 <a:ea typeface="Georgia" pitchFamily="34" charset="-122"/>
                 <a:cs typeface="Georgia" pitchFamily="34" charset="-120"/>
               </a:rPr>
-              <a:t>Say this instead: This is a portrait of the letters you already use. We read the username you walk around in. The number is a fit of materials, not a reason to stay or leave. A low day is weather. Do a small necessary thing. The total is something the name can carry. It is not the name. Greek is a second instrument. Do not translate it into Latin in the room.</a:t>
-            </a:r>
-            <a:endParaRPr lang="en-US" sz="1800" dirty="0"/>
+              <a:t>Flip the tongue when you want that instrument. Do not translate one into the other in the room. Collapsing II honest instruments into I map is the number brain’s favorite kindness.</a:t>
+            </a:r>
+            <a:endParaRPr lang="en-US" sz="1600" dirty="0"/>
           </a:p>
         </p:txBody>
       </p:sp>
@@ -3389,7 +3373,7 @@
                 <a:ea typeface="Georgia" pitchFamily="34" charset="-122"/>
                 <a:cs typeface="Georgia" pitchFamily="34" charset="-120"/>
               </a:rPr>
-              <a:t>CC33 · letterology.club  ·  13 / 14</a:t>
+              <a:t>CC33 · letterology.club  ·  XIII · XV</a:t>
             </a:r>
             <a:endParaRPr lang="en-US" sz="1100" dirty="0"/>
           </a:p>
@@ -3510,7 +3494,7 @@
                 <a:ea typeface="Georgia" pitchFamily="34" charset="-122"/>
                 <a:cs typeface="Georgia" pitchFamily="34" charset="-120"/>
               </a:rPr>
-              <a:t>THE CLOSE</a:t>
+              <a:t>SPEECH</a:t>
             </a:r>
             <a:endParaRPr lang="en-US" sz="1200" dirty="0"/>
           </a:p>
@@ -3549,7 +3533,7 @@
                 <a:ea typeface="Georgia" pitchFamily="34" charset="-122"/>
                 <a:cs typeface="Georgia" pitchFamily="34" charset="-120"/>
               </a:rPr>
-              <a:t>How you leave the room</a:t>
+              <a:t>Never say this. Say this instead.</a:t>
             </a:r>
             <a:endParaRPr lang="en-US" sz="3200" dirty="0"/>
           </a:p>
@@ -3583,7 +3567,7 @@
               <a:buNone/>
             </a:pPr>
             <a:r>
-              <a:rPr lang="en-US" sz="1800" dirty="0">
+              <a:rPr lang="en-US" sz="1600" dirty="0">
                 <a:solidFill>
                   <a:srgbClr val="1C1712"/>
                 </a:solidFill>
@@ -3591,10 +3575,231 @@
                 <a:ea typeface="Georgia" pitchFamily="34" charset="-122"/>
                 <a:cs typeface="Georgia" pitchFamily="34" charset="-120"/>
               </a:rPr>
-              <a:t>Open letterology.club. Type their username. Read the path and today’s luck.</a:t>
-            </a:r>
-            <a:endParaRPr lang="en-US" sz="1800" dirty="0"/>
-          </a:p>
+              <a:t>If destiny, legal-name supremacy, or a lucky pile is coming out of your mouth, stop. The cheat sheet carries the same list, so nobody has to memorize Why.</a:t>
+            </a:r>
+            <a:endParaRPr lang="en-US" sz="1600" dirty="0"/>
+          </a:p>
+        </p:txBody>
+      </p:sp>
+      <p:sp>
+        <p:nvSpPr>
+          <p:cNvPr id="6" name="Text 4"/>
+          <p:cNvSpPr/>
+          <p:nvPr/>
+        </p:nvSpPr>
+        <p:spPr>
+          <a:xfrm>
+            <a:off x="640080" y="6355080"/>
+            <a:ext cx="10789920" cy="274320"/>
+          </a:xfrm>
+          <a:prstGeom prst="rect">
+            <a:avLst/>
+          </a:prstGeom>
+          <a:noFill/>
+          <a:ln/>
+        </p:spPr>
+        <p:txBody>
+          <a:bodyPr wrap="square" lIns="0" tIns="0" rIns="0" bIns="0" rtlCol="0" anchor="ctr"/>
+          <a:lstStyle/>
+          <a:p>
+            <a:pPr indent="0" marL="0">
+              <a:buNone/>
+            </a:pPr>
+            <a:r>
+              <a:rPr lang="en-US" sz="1100" dirty="0">
+                <a:solidFill>
+                  <a:srgbClr val="6B6256"/>
+                </a:solidFill>
+                <a:latin typeface="Georgia" pitchFamily="34" charset="0"/>
+                <a:ea typeface="Georgia" pitchFamily="34" charset="-122"/>
+                <a:cs typeface="Georgia" pitchFamily="34" charset="-120"/>
+              </a:rPr>
+              <a:t>CC33 · letterology.club  ·  XIV · XV</a:t>
+            </a:r>
+            <a:endParaRPr lang="en-US" sz="1100" dirty="0"/>
+          </a:p>
+        </p:txBody>
+      </p:sp>
+      <p:sp>
+        <p:nvSpPr>
+          <p:cNvPr id="8" name="Shape 5"/>
+          <p:cNvSpPr/>
+          <p:nvPr/>
+        </p:nvSpPr>
+        <p:spPr>
+          <a:xfrm>
+            <a:off x="640080" y="6217920"/>
+            <a:ext cx="2011680" cy="36576"/>
+          </a:xfrm>
+          <a:prstGeom prst="rect">
+            <a:avLst/>
+          </a:prstGeom>
+          <a:solidFill>
+            <a:srgbClr val="F6F0E4"/>
+          </a:solidFill>
+          <a:ln w="12700">
+            <a:solidFill>
+              <a:srgbClr val="7A3328"/>
+            </a:solidFill>
+            <a:prstDash val="solid"/>
+          </a:ln>
+        </p:spPr>
+      </p:sp>
+    </p:spTree>
+  </p:cSld>
+  <p:clrMapOvr>
+    <a:masterClrMapping/>
+  </p:clrMapOvr>
+</p:sld>
+</file>
+
+<file path=ppt/slides/slide15.xml><?xml version="1.0" encoding="utf-8"?>
+<p:sld xmlns:a="http://schemas.openxmlformats.org/drawingml/2006/main" xmlns:r="http://schemas.openxmlformats.org/officeDocument/2006/relationships" xmlns:p="http://schemas.openxmlformats.org/presentationml/2006/main">
+  <p:cSld name="Slide 15">
+    <p:bg>
+      <p:bgPr>
+        <a:solidFill>
+          <a:srgbClr val="EFE6D6"/>
+        </a:solidFill>
+      </p:bgPr>
+    </p:bg>
+    <p:spTree>
+      <p:nvGrpSpPr>
+        <p:cNvPr id="1" name=""/>
+        <p:cNvGrpSpPr/>
+        <p:nvPr/>
+      </p:nvGrpSpPr>
+      <p:grpSpPr>
+        <a:xfrm>
+          <a:off x="0" y="0"/>
+          <a:ext cx="0" cy="0"/>
+          <a:chOff x="0" y="0"/>
+          <a:chExt cx="0" cy="0"/>
+        </a:xfrm>
+      </p:grpSpPr>
+      <p:sp>
+        <p:nvSpPr>
+          <p:cNvPr id="2" name="Shape 0"/>
+          <p:cNvSpPr/>
+          <p:nvPr/>
+        </p:nvSpPr>
+        <p:spPr>
+          <a:xfrm>
+            <a:off x="0" y="0"/>
+            <a:ext cx="164592" cy="6858000"/>
+          </a:xfrm>
+          <a:prstGeom prst="rect">
+            <a:avLst/>
+          </a:prstGeom>
+          <a:solidFill>
+            <a:srgbClr val="7A3328"/>
+          </a:solidFill>
+          <a:ln w="12700">
+            <a:solidFill>
+              <a:srgbClr val="7A3328"/>
+            </a:solidFill>
+            <a:prstDash val="solid"/>
+          </a:ln>
+        </p:spPr>
+      </p:sp>
+      <p:sp>
+        <p:nvSpPr>
+          <p:cNvPr id="3" name="Text 1"/>
+          <p:cNvSpPr/>
+          <p:nvPr/>
+        </p:nvSpPr>
+        <p:spPr>
+          <a:xfrm>
+            <a:off x="640080" y="320040"/>
+            <a:ext cx="10789920" cy="320040"/>
+          </a:xfrm>
+          <a:prstGeom prst="rect">
+            <a:avLst/>
+          </a:prstGeom>
+          <a:noFill/>
+          <a:ln/>
+        </p:spPr>
+        <p:txBody>
+          <a:bodyPr wrap="square" lIns="0" tIns="0" rIns="0" bIns="0" rtlCol="0" anchor="ctr"/>
+          <a:lstStyle/>
+          <a:p>
+            <a:pPr indent="0" marL="0">
+              <a:buNone/>
+            </a:pPr>
+            <a:r>
+              <a:rPr lang="en-US" sz="1200" spc="300" kern="0" dirty="0">
+                <a:solidFill>
+                  <a:srgbClr val="6B6256"/>
+                </a:solidFill>
+                <a:latin typeface="Georgia" pitchFamily="34" charset="0"/>
+                <a:ea typeface="Georgia" pitchFamily="34" charset="-122"/>
+                <a:cs typeface="Georgia" pitchFamily="34" charset="-120"/>
+              </a:rPr>
+              <a:t>THE CLOSE</a:t>
+            </a:r>
+            <a:endParaRPr lang="en-US" sz="1200" dirty="0"/>
+          </a:p>
+        </p:txBody>
+      </p:sp>
+      <p:sp>
+        <p:nvSpPr>
+          <p:cNvPr id="4" name="Text 2"/>
+          <p:cNvSpPr/>
+          <p:nvPr/>
+        </p:nvSpPr>
+        <p:spPr>
+          <a:xfrm>
+            <a:off x="640080" y="685800"/>
+            <a:ext cx="10789920" cy="1005840"/>
+          </a:xfrm>
+          <a:prstGeom prst="rect">
+            <a:avLst/>
+          </a:prstGeom>
+          <a:noFill/>
+          <a:ln/>
+        </p:spPr>
+        <p:txBody>
+          <a:bodyPr wrap="square" lIns="0" tIns="0" rIns="0" bIns="0" rtlCol="0" anchor="t"/>
+          <a:lstStyle/>
+          <a:p>
+            <a:pPr indent="0" marL="0">
+              <a:buNone/>
+            </a:pPr>
+            <a:r>
+              <a:rPr lang="en-US" sz="3200" b="1" dirty="0">
+                <a:solidFill>
+                  <a:srgbClr val="1C1712"/>
+                </a:solidFill>
+                <a:latin typeface="Georgia" pitchFamily="34" charset="0"/>
+                <a:ea typeface="Georgia" pitchFamily="34" charset="-122"/>
+                <a:cs typeface="Georgia" pitchFamily="34" charset="-120"/>
+              </a:rPr>
+              <a:t>How you leave the room</a:t>
+            </a:r>
+            <a:endParaRPr lang="en-US" sz="3200" dirty="0"/>
+          </a:p>
+        </p:txBody>
+      </p:sp>
+      <p:sp>
+        <p:nvSpPr>
+          <p:cNvPr id="5" name="Text 3"/>
+          <p:cNvSpPr/>
+          <p:nvPr/>
+        </p:nvSpPr>
+        <p:spPr>
+          <a:xfrm>
+            <a:off x="640080" y="1828800"/>
+            <a:ext cx="10789920" cy="4114800"/>
+          </a:xfrm>
+          <a:prstGeom prst="rect">
+            <a:avLst/>
+          </a:prstGeom>
+          <a:noFill/>
+          <a:ln/>
+        </p:spPr>
+        <p:txBody>
+          <a:bodyPr wrap="square" lIns="0" tIns="0" rIns="0" bIns="0" rtlCol="0" anchor="t"/>
+          <a:lstStyle/>
           <a:p>
             <a:pPr indent="0" marL="0">
               <a:spcAft>
@@ -3603,7 +3808,7 @@
               <a:buNone/>
             </a:pPr>
             <a:r>
-              <a:rPr lang="en-US" sz="1800" dirty="0">
+              <a:rPr lang="en-US" sz="1600" dirty="0">
                 <a:solidFill>
                   <a:srgbClr val="1C1712"/>
                 </a:solidFill>
@@ -3611,9 +3816,9 @@
                 <a:ea typeface="Georgia" pitchFamily="34" charset="-122"/>
                 <a:cs typeface="Georgia" pitchFamily="34" charset="-120"/>
               </a:rPr>
-              <a:t>Give them one thing they can do before noon. Then stop talking.</a:t>
-            </a:r>
-            <a:endParaRPr lang="en-US" sz="1800" dirty="0"/>
+              <a:t>Open letterology.club. Type their username. Read the path and today’s luck. Give them I thing they can do before noon. Then stop talking.</a:t>
+            </a:r>
+            <a:endParaRPr lang="en-US" sz="1600" dirty="0"/>
           </a:p>
           <a:p>
             <a:pPr indent="0" marL="0">
@@ -3623,7 +3828,7 @@
               <a:buNone/>
             </a:pPr>
             <a:r>
-              <a:rPr lang="en-US" sz="1800" dirty="0">
+              <a:rPr lang="en-US" sz="1600" dirty="0">
                 <a:solidFill>
                   <a:srgbClr val="1C1712"/>
                 </a:solidFill>
@@ -3631,9 +3836,9 @@
                 <a:ea typeface="Georgia" pitchFamily="34" charset="-122"/>
                 <a:cs typeface="Georgia" pitchFamily="34" charset="-120"/>
               </a:rPr>
-              <a:t>Point them at Why if they want the argument, and at the cheat sheet if they will read someone else tomorrow.</a:t>
-            </a:r>
-            <a:endParaRPr lang="en-US" sz="1800" dirty="0"/>
+              <a:t>Point them at Why if they want the argument, at the cheat sheet if they will read someone else tomorrow, and at the portrait of looking if they want to see their own Letter brain.</a:t>
+            </a:r>
+            <a:endParaRPr lang="en-US" sz="1600" dirty="0"/>
           </a:p>
           <a:p>
             <a:pPr indent="0" marL="0">
@@ -3643,7 +3848,7 @@
               <a:buNone/>
             </a:pPr>
             <a:r>
-              <a:rPr lang="en-US" sz="1800" dirty="0">
+              <a:rPr lang="en-US" sz="1600" dirty="0">
                 <a:solidFill>
                   <a:srgbClr val="1C1712"/>
                 </a:solidFill>
@@ -3653,7 +3858,7 @@
               </a:rPr>
               <a:t>See the whole. Use the pieces. Come back. The decision is yours.</a:t>
             </a:r>
-            <a:endParaRPr lang="en-US" sz="1800" dirty="0"/>
+            <a:endParaRPr lang="en-US" sz="1600" dirty="0"/>
           </a:p>
         </p:txBody>
       </p:sp>
@@ -3690,7 +3895,7 @@
                 <a:ea typeface="Georgia" pitchFamily="34" charset="-122"/>
                 <a:cs typeface="Georgia" pitchFamily="34" charset="-120"/>
               </a:rPr>
-              <a:t>CC33 · letterology.club  ·  14 / 14</a:t>
+              <a:t>CC33 · letterology.club  ·  XV · XV</a:t>
             </a:r>
             <a:endParaRPr lang="en-US" sz="1100" dirty="0"/>
           </a:p>
@@ -3850,7 +4055,7 @@
                 <a:ea typeface="Georgia" pitchFamily="34" charset="-122"/>
                 <a:cs typeface="Georgia" pitchFamily="34" charset="-120"/>
               </a:rPr>
-              <a:t>What this is for</a:t>
+              <a:t>What you should be able to do when we finish</a:t>
             </a:r>
             <a:endParaRPr lang="en-US" sz="3200" dirty="0"/>
           </a:p>
@@ -3884,7 +4089,7 @@
               <a:buNone/>
             </a:pPr>
             <a:r>
-              <a:rPr lang="en-US" sz="1800" dirty="0">
+              <a:rPr lang="en-US" sz="1600" dirty="0">
                 <a:solidFill>
                   <a:srgbClr val="1C1712"/>
                 </a:solidFill>
@@ -3892,9 +4097,9 @@
                 <a:ea typeface="Georgia" pitchFamily="34" charset="-122"/>
                 <a:cs typeface="Georgia" pitchFamily="34" charset="-120"/>
               </a:rPr>
-              <a:t>After this you should be able to read a username out loud.</a:t>
-            </a:r>
-            <a:endParaRPr lang="en-US" sz="1800" dirty="0"/>
+              <a:t>You should be able to take the username someone actually uses and read it out loud as a path: how they enter, how they tend to work, and where that work wants to happen.</a:t>
+            </a:r>
+            <a:endParaRPr lang="en-US" sz="1600" dirty="0"/>
           </a:p>
           <a:p>
             <a:pPr indent="0" marL="0">
@@ -3904,7 +4109,7 @@
               <a:buNone/>
             </a:pPr>
             <a:r>
-              <a:rPr lang="en-US" sz="1800" dirty="0">
+              <a:rPr lang="en-US" sz="1600" dirty="0">
                 <a:solidFill>
                   <a:srgbClr val="1C1712"/>
                 </a:solidFill>
@@ -3912,9 +4117,9 @@
                 <a:ea typeface="Georgia" pitchFamily="34" charset="-122"/>
                 <a:cs typeface="Georgia" pitchFamily="34" charset="-120"/>
               </a:rPr>
-              <a:t>You should be able to time a decision against today.</a:t>
-            </a:r>
-            <a:endParaRPr lang="en-US" sz="1800" dirty="0"/>
+              <a:t>You should be able to hold that path up against today and say whether the day will have the move, without turning weather into fate.</a:t>
+            </a:r>
+            <a:endParaRPr lang="en-US" sz="1600" dirty="0"/>
           </a:p>
           <a:p>
             <a:pPr indent="0" marL="0">
@@ -3924,7 +4129,7 @@
               <a:buNone/>
             </a:pPr>
             <a:r>
-              <a:rPr lang="en-US" sz="1800" dirty="0">
+              <a:rPr lang="en-US" sz="1600" dirty="0">
                 <a:solidFill>
                   <a:srgbClr val="1C1712"/>
                 </a:solidFill>
@@ -3932,9 +4137,9 @@
                 <a:ea typeface="Georgia" pitchFamily="34" charset="-122"/>
                 <a:cs typeface="Georgia" pitchFamily="34" charset="-120"/>
               </a:rPr>
-              <a:t>You should be able to hand someone a card without turning it into a sermon.</a:t>
-            </a:r>
-            <a:endParaRPr lang="en-US" sz="1800" dirty="0"/>
+              <a:t>You should be able to hand them a card and leave the room. If you are still explaining yourself after that, you are preaching.</a:t>
+            </a:r>
+            <a:endParaRPr lang="en-US" sz="1600" dirty="0"/>
           </a:p>
         </p:txBody>
       </p:sp>
@@ -3971,7 +4176,7 @@
                 <a:ea typeface="Georgia" pitchFamily="34" charset="-122"/>
                 <a:cs typeface="Georgia" pitchFamily="34" charset="-120"/>
               </a:rPr>
-              <a:t>CC33 · letterology.club  ·  2 / 14</a:t>
+              <a:t>CC33 · letterology.club  ·  II · XV</a:t>
             </a:r>
             <a:endParaRPr lang="en-US" sz="1100" dirty="0"/>
           </a:p>
@@ -4092,7 +4297,7 @@
                 <a:ea typeface="Georgia" pitchFamily="34" charset="-122"/>
                 <a:cs typeface="Georgia" pitchFamily="34" charset="-120"/>
               </a:rPr>
-              <a:t>THE REFUSAL</a:t>
+              <a:t>THE WHOLE POINT</a:t>
             </a:r>
             <a:endParaRPr lang="en-US" sz="1200" dirty="0"/>
           </a:p>
@@ -4131,7 +4336,7 @@
                 <a:ea typeface="Georgia" pitchFamily="34" charset="-122"/>
                 <a:cs typeface="Georgia" pitchFamily="34" charset="-120"/>
               </a:rPr>
-              <a:t>We do not add a name into a lucky number</a:t>
+              <a:t>A Letter brain and a number brain are II habits of attention</a:t>
             </a:r>
             <a:endParaRPr lang="en-US" sz="3200" dirty="0"/>
           </a:p>
@@ -4165,7 +4370,7 @@
               <a:buNone/>
             </a:pPr>
             <a:r>
-              <a:rPr lang="en-US" sz="1800" dirty="0">
+              <a:rPr lang="en-US" sz="1600" dirty="0">
                 <a:solidFill>
                   <a:srgbClr val="1C1712"/>
                 </a:solidFill>
@@ -4173,9 +4378,9 @@
                 <a:ea typeface="Georgia" pitchFamily="34" charset="-122"/>
                 <a:cs typeface="Georgia" pitchFamily="34" charset="-120"/>
               </a:rPr>
-              <a:t>Numerology takes a name apart, assigns numbers, adds them, and treats the total as the person.</a:t>
-            </a:r>
-            <a:endParaRPr lang="en-US" sz="1800" dirty="0"/>
+              <a:t>They are not II species of person. Most of us use both before lunch. The club trains habit I, and it keeps habit II from becoming king.</a:t>
+            </a:r>
+            <a:endParaRPr lang="en-US" sz="1600" dirty="0"/>
           </a:p>
           <a:p>
             <a:pPr indent="0" marL="0">
@@ -4185,7 +4390,7 @@
               <a:buNone/>
             </a:pPr>
             <a:r>
-              <a:rPr lang="en-US" sz="1800" dirty="0">
+              <a:rPr lang="en-US" sz="1600" dirty="0">
                 <a:solidFill>
                   <a:srgbClr val="1C1712"/>
                 </a:solidFill>
@@ -4193,9 +4398,9 @@
                 <a:ea typeface="Georgia" pitchFamily="34" charset="-122"/>
                 <a:cs typeface="Georgia" pitchFamily="34" charset="-120"/>
               </a:rPr>
-              <a:t>We keep the suspicion that a name means something.</a:t>
-            </a:r>
-            <a:endParaRPr lang="en-US" sz="1800" dirty="0"/>
+              <a:t>Start with the living thing. You begin with the person in the room: this username, this day, this act they will stand behind. You read the marks they already put into the world, and you treat those marks as a face you can meet. Letters are how a life shows up in public. A Letter brain stays with that face long enough to see it, and only then notices the details that would help a clerk.</a:t>
+            </a:r>
+            <a:endParaRPr lang="en-US" sz="1600" dirty="0"/>
           </a:p>
           <a:p>
             <a:pPr indent="0" marL="0">
@@ -4205,7 +4410,7 @@
               <a:buNone/>
             </a:pPr>
             <a:r>
-              <a:rPr lang="en-US" sz="1800" dirty="0">
+              <a:rPr lang="en-US" sz="1600" dirty="0">
                 <a:solidFill>
                   <a:srgbClr val="1C1712"/>
                 </a:solidFill>
@@ -4213,9 +4418,29 @@
                 <a:ea typeface="Georgia" pitchFamily="34" charset="-122"/>
                 <a:cs typeface="Georgia" pitchFamily="34" charset="-120"/>
               </a:rPr>
-              <a:t>We throw out the last step, because a total is not a person.</a:t>
-            </a:r>
-            <a:endParaRPr lang="en-US" sz="1800" dirty="0"/>
+              <a:t>Start with what can be filed. You begin with rank, year, price, a lucky pile someone can hold in I hand. That habit is excellent for storage, for clocks, for a drawer of M lives. It becomes a problem when the filing is treated as the person, and the face is thrown away so the drawer will close.</a:t>
+            </a:r>
+            <a:endParaRPr lang="en-US" sz="1600" dirty="0"/>
+          </a:p>
+          <a:p>
+            <a:pPr indent="0" marL="0">
+              <a:spcAft>
+                <a:spcPts val="1000"/>
+              </a:spcAft>
+              <a:buNone/>
+            </a:pPr>
+            <a:r>
+              <a:rPr lang="en-US" sz="1600" dirty="0">
+                <a:solidFill>
+                  <a:srgbClr val="1C1712"/>
+                </a:solidFill>
+                <a:latin typeface="Georgia" pitchFamily="34" charset="0"/>
+                <a:ea typeface="Georgia" pitchFamily="34" charset="-122"/>
+                <a:cs typeface="Georgia" pitchFamily="34" charset="-120"/>
+              </a:rPr>
+              <a:t>Iain McGilchrist told this as the fable of the Master and his Emissary. The Master looks at the whole living thing in the room. The Emissary goes out to file, measure, and sort, then is supposed to come home and report. We take the fable, not the brain maps. A Letter brain is the Master at work. A number brain is the Emissary who stayed out so long he forgot there was a face to return to.</a:t>
+            </a:r>
+            <a:endParaRPr lang="en-US" sz="1600" dirty="0"/>
           </a:p>
         </p:txBody>
       </p:sp>
@@ -4252,7 +4477,7 @@
                 <a:ea typeface="Georgia" pitchFamily="34" charset="-122"/>
                 <a:cs typeface="Georgia" pitchFamily="34" charset="-120"/>
               </a:rPr>
-              <a:t>CC33 · letterology.club  ·  3 / 14</a:t>
+              <a:t>CC33 · letterology.club  ·  III · XV</a:t>
             </a:r>
             <a:endParaRPr lang="en-US" sz="1100" dirty="0"/>
           </a:p>
@@ -4373,7 +4598,7 @@
                 <a:ea typeface="Georgia" pitchFamily="34" charset="-122"/>
                 <a:cs typeface="Georgia" pitchFamily="34" charset="-120"/>
               </a:rPr>
-              <a:t>THE CIRCUIT</a:t>
+              <a:t>THE REFUSAL</a:t>
             </a:r>
             <a:endParaRPr lang="en-US" sz="1200" dirty="0"/>
           </a:p>
@@ -4412,7 +4637,7 @@
                 <a:ea typeface="Georgia" pitchFamily="34" charset="-122"/>
                 <a:cs typeface="Georgia" pitchFamily="34" charset="-120"/>
               </a:rPr>
-              <a:t>See the whole. Use the pieces. Come back.</a:t>
+              <a:t>We keep the suspicion. We throw out the last step.</a:t>
             </a:r>
             <a:endParaRPr lang="en-US" sz="3200" dirty="0"/>
           </a:p>
@@ -4446,7 +4671,7 @@
               <a:buNone/>
             </a:pPr>
             <a:r>
-              <a:rPr lang="en-US" sz="1800" dirty="0">
+              <a:rPr lang="en-US" sz="1600" dirty="0">
                 <a:solidFill>
                   <a:srgbClr val="1C1712"/>
                 </a:solidFill>
@@ -4454,9 +4679,9 @@
                 <a:ea typeface="Georgia" pitchFamily="34" charset="-122"/>
                 <a:cs typeface="Georgia" pitchFamily="34" charset="-120"/>
               </a:rPr>
-              <a:t>First look at the whole living thing: this username, this day, this act you will stand behind.</a:t>
-            </a:r>
-            <a:endParaRPr lang="en-US" sz="1800" dirty="0"/>
+              <a:t>Numerology was right that a name is not noise. A person chose some letters, or lived inside them long enough that those letters do work, and that is already a fact worth reading.</a:t>
+            </a:r>
+            <a:endParaRPr lang="en-US" sz="1600" dirty="0"/>
           </a:p>
           <a:p>
             <a:pPr indent="0" marL="0">
@@ -4466,7 +4691,7 @@
               <a:buNone/>
             </a:pPr>
             <a:r>
-              <a:rPr lang="en-US" sz="1800" dirty="0">
+              <a:rPr lang="en-US" sz="1600" dirty="0">
                 <a:solidFill>
                   <a:srgbClr val="1C1712"/>
                 </a:solidFill>
@@ -4474,9 +4699,9 @@
                 <a:ea typeface="Georgia" pitchFamily="34" charset="-122"/>
                 <a:cs typeface="Georgia" pitchFamily="34" charset="-120"/>
               </a:rPr>
-              <a:t>Then you may count letters, dates, and sums. Those counts are useful.</a:t>
-            </a:r>
-            <a:endParaRPr lang="en-US" sz="1800" dirty="0"/>
+              <a:t>It was wrong about what to do next. It broke the name into values, piled them, and called the pile a soul. That last step is a clerk’s trick. It is a poor way to look at someone you actually know.</a:t>
+            </a:r>
+            <a:endParaRPr lang="en-US" sz="1600" dirty="0"/>
           </a:p>
           <a:p>
             <a:pPr indent="0" marL="0">
@@ -4486,7 +4711,7 @@
               <a:buNone/>
             </a:pPr>
             <a:r>
-              <a:rPr lang="en-US" sz="1800" dirty="0">
+              <a:rPr lang="en-US" sz="1600" dirty="0">
                 <a:solidFill>
                   <a:srgbClr val="1C1712"/>
                 </a:solidFill>
@@ -4494,29 +4719,9 @@
                 <a:ea typeface="Georgia" pitchFamily="34" charset="-122"/>
                 <a:cs typeface="Georgia" pitchFamily="34" charset="-120"/>
               </a:rPr>
-              <a:t>Then you look back at the person they came from.</a:t>
-            </a:r>
-            <a:endParaRPr lang="en-US" sz="1800" dirty="0"/>
-          </a:p>
-          <a:p>
-            <a:pPr indent="0" marL="0">
-              <a:spcAft>
-                <a:spcPts val="1000"/>
-              </a:spcAft>
-              <a:buNone/>
-            </a:pPr>
-            <a:r>
-              <a:rPr lang="en-US" sz="1800" dirty="0">
-                <a:solidFill>
-                  <a:srgbClr val="1C1712"/>
-                </a:solidFill>
-                <a:latin typeface="Georgia" pitchFamily="34" charset="0"/>
-                <a:ea typeface="Georgia" pitchFamily="34" charset="-122"/>
-                <a:cs typeface="Georgia" pitchFamily="34" charset="-120"/>
-              </a:rPr>
-              <a:t>Iain McGilchrist called those two ways of seeing the Master and the Emissary. The Master looks at the whole. The Emissary looks at pieces. The Emissary is a good servant and a bad king. We take the fable, not the brain maps.</a:t>
-            </a:r>
-            <a:endParaRPr lang="en-US" sz="1800" dirty="0"/>
+              <a:t>Letterology keeps the suspicion and refuses the pile. The person was the whole name the pile could not hold.</a:t>
+            </a:r>
+            <a:endParaRPr lang="en-US" sz="1600" dirty="0"/>
           </a:p>
         </p:txBody>
       </p:sp>
@@ -4553,7 +4758,7 @@
                 <a:ea typeface="Georgia" pitchFamily="34" charset="-122"/>
                 <a:cs typeface="Georgia" pitchFamily="34" charset="-120"/>
               </a:rPr>
-              <a:t>CC33 · letterology.club  ·  4 / 14</a:t>
+              <a:t>CC33 · letterology.club  ·  IV · XV</a:t>
             </a:r>
             <a:endParaRPr lang="en-US" sz="1100" dirty="0"/>
           </a:p>
@@ -4674,7 +4879,7 @@
                 <a:ea typeface="Georgia" pitchFamily="34" charset="-122"/>
                 <a:cs typeface="Georgia" pitchFamily="34" charset="-120"/>
               </a:rPr>
-              <a:t>THE MATERIAL</a:t>
+              <a:t>THE PRACTICE</a:t>
             </a:r>
             <a:endParaRPr lang="en-US" sz="1200" dirty="0"/>
           </a:p>
@@ -4713,7 +4918,7 @@
                 <a:ea typeface="Georgia" pitchFamily="34" charset="-122"/>
                 <a:cs typeface="Georgia" pitchFamily="34" charset="-120"/>
               </a:rPr>
-              <a:t>We read the username you use</a:t>
+              <a:t>Look. Notice. Look back.</a:t>
             </a:r>
             <a:endParaRPr lang="en-US" sz="3200" dirty="0"/>
           </a:p>
@@ -4747,7 +4952,7 @@
               <a:buNone/>
             </a:pPr>
             <a:r>
-              <a:rPr lang="en-US" sz="1800" dirty="0">
+              <a:rPr lang="en-US" sz="1600" dirty="0">
                 <a:solidFill>
                   <a:srgbClr val="1C1712"/>
                 </a:solidFill>
@@ -4755,9 +4960,9 @@
                 <a:ea typeface="Georgia" pitchFamily="34" charset="-122"/>
                 <a:cs typeface="Georgia" pitchFamily="34" charset="-120"/>
               </a:rPr>
-              <a:t>A legal name was given before you could refuse it.</a:t>
-            </a:r>
-            <a:endParaRPr lang="en-US" sz="1800" dirty="0"/>
+              <a:t>A Letter brain does not refuse detail. It refuses to stop at detail. After you have looked closely at the letters of a name, a day, or an act, you look back at the human they came from.</a:t>
+            </a:r>
+            <a:endParaRPr lang="en-US" sz="1600" dirty="0"/>
           </a:p>
           <a:p>
             <a:pPr indent="0" marL="0">
@@ -4767,7 +4972,7 @@
               <a:buNone/>
             </a:pPr>
             <a:r>
-              <a:rPr lang="en-US" sz="1800" dirty="0">
+              <a:rPr lang="en-US" sz="1600" dirty="0">
                 <a:solidFill>
                   <a:srgbClr val="1C1712"/>
                 </a:solidFill>
@@ -4775,9 +4980,9 @@
                 <a:ea typeface="Georgia" pitchFamily="34" charset="-122"/>
                 <a:cs typeface="Georgia" pitchFamily="34" charset="-120"/>
               </a:rPr>
-              <a:t>A username is the name you walk around in.</a:t>
-            </a:r>
-            <a:endParaRPr lang="en-US" sz="1800" dirty="0"/>
+              <a:t>That last look is the whole practice. Without it you have a clever filing system with nicer stationery. With it, the details report home, and the person remains the person.</a:t>
+            </a:r>
+            <a:endParaRPr lang="en-US" sz="1600" dirty="0"/>
           </a:p>
           <a:p>
             <a:pPr indent="0" marL="0">
@@ -4787,7 +4992,7 @@
               <a:buNone/>
             </a:pPr>
             <a:r>
-              <a:rPr lang="en-US" sz="1800" dirty="0">
+              <a:rPr lang="en-US" sz="1600" dirty="0">
                 <a:solidFill>
                   <a:srgbClr val="1C1712"/>
                 </a:solidFill>
@@ -4795,9 +5000,9 @@
                 <a:ea typeface="Georgia" pitchFamily="34" charset="-122"/>
                 <a:cs typeface="Georgia" pitchFamily="34" charset="-120"/>
               </a:rPr>
-              <a:t>We read A through Z of that handle. Digits become letters. Accents fall away.</a:t>
-            </a:r>
-            <a:endParaRPr lang="en-US" sz="1800" dirty="0"/>
+              <a:t>See the whole. Use the pieces. Come back. The decision is yours.</a:t>
+            </a:r>
+            <a:endParaRPr lang="en-US" sz="1600" dirty="0"/>
           </a:p>
         </p:txBody>
       </p:sp>
@@ -4834,7 +5039,7 @@
                 <a:ea typeface="Georgia" pitchFamily="34" charset="-122"/>
                 <a:cs typeface="Georgia" pitchFamily="34" charset="-120"/>
               </a:rPr>
-              <a:t>CC33 · letterology.club  ·  5 / 14</a:t>
+              <a:t>CC33 · letterology.club  ·  V · XV</a:t>
             </a:r>
             <a:endParaRPr lang="en-US" sz="1100" dirty="0"/>
           </a:p>
@@ -4955,7 +5160,7 @@
                 <a:ea typeface="Georgia" pitchFamily="34" charset="-122"/>
                 <a:cs typeface="Georgia" pitchFamily="34" charset="-120"/>
               </a:rPr>
-              <a:t>THE PATH</a:t>
+              <a:t>THE MATERIAL</a:t>
             </a:r>
             <a:endParaRPr lang="en-US" sz="1200" dirty="0"/>
           </a:p>
@@ -4994,7 +5199,7 @@
                 <a:ea typeface="Georgia" pitchFamily="34" charset="-122"/>
                 <a:cs typeface="Georgia" pitchFamily="34" charset="-120"/>
               </a:rPr>
-              <a:t>How a Latin reading works</a:t>
+              <a:t>We read the username you walk around in</a:t>
             </a:r>
             <a:endParaRPr lang="en-US" sz="3200" dirty="0"/>
           </a:p>
@@ -5028,7 +5233,7 @@
               <a:buNone/>
             </a:pPr>
             <a:r>
-              <a:rPr lang="en-US" sz="1800" dirty="0">
+              <a:rPr lang="en-US" sz="1600" dirty="0">
                 <a:solidFill>
                   <a:srgbClr val="1C1712"/>
                 </a:solidFill>
@@ -5036,9 +5241,9 @@
                 <a:ea typeface="Georgia" pitchFamily="34" charset="-122"/>
                 <a:cs typeface="Georgia" pitchFamily="34" charset="-120"/>
               </a:rPr>
-              <a:t>The first letter of the first word is the role, which is how you enter.</a:t>
-            </a:r>
-            <a:endParaRPr lang="en-US" sz="1800" dirty="0"/>
+              <a:t>A legal name was spoken over you before you could refuse it. It belongs to a record office. A username is the name that does work in public: you chose it, or you lived inside it long enough that it became another skin.</a:t>
+            </a:r>
+            <a:endParaRPr lang="en-US" sz="1600" dirty="0"/>
           </a:p>
           <a:p>
             <a:pPr indent="0" marL="0">
@@ -5048,7 +5253,7 @@
               <a:buNone/>
             </a:pPr>
             <a:r>
-              <a:rPr lang="en-US" sz="1800" dirty="0">
+              <a:rPr lang="en-US" sz="1600" dirty="0">
                 <a:solidFill>
                   <a:srgbClr val="1C1712"/>
                 </a:solidFill>
@@ -5056,49 +5261,9 @@
                 <a:ea typeface="Georgia" pitchFamily="34" charset="-122"/>
                 <a:cs typeface="Georgia" pitchFamily="34" charset="-120"/>
               </a:rPr>
-              <a:t>After that we count which letters return most often, including extra weight at the edges of a word.</a:t>
-            </a:r>
-            <a:endParaRPr lang="en-US" sz="1800" dirty="0"/>
-          </a:p>
-          <a:p>
-            <a:pPr indent="0" marL="0">
-              <a:spcAft>
-                <a:spcPts val="1000"/>
-              </a:spcAft>
-              <a:buNone/>
-            </a:pPr>
-            <a:r>
-              <a:rPr lang="en-US" sz="1800" dirty="0">
-                <a:solidFill>
-                  <a:srgbClr val="1C1712"/>
-                </a:solidFill>
-                <a:latin typeface="Georgia" pitchFamily="34" charset="0"/>
-                <a:ea typeface="Georgia" pitchFamily="34" charset="-122"/>
-                <a:cs typeface="Georgia" pitchFamily="34" charset="-120"/>
-              </a:rPr>
-              <a:t>The next two heaviest letters are how you tend to work, and where that work wants to happen.</a:t>
-            </a:r>
-            <a:endParaRPr lang="en-US" sz="1800" dirty="0"/>
-          </a:p>
-          <a:p>
-            <a:pPr indent="0" marL="0">
-              <a:spcAft>
-                <a:spcPts val="1000"/>
-              </a:spcAft>
-              <a:buNone/>
-            </a:pPr>
-            <a:r>
-              <a:rPr lang="en-US" sz="1800" dirty="0">
-                <a:solidFill>
-                  <a:srgbClr val="1C1712"/>
-                </a:solidFill>
-                <a:latin typeface="Georgia" pitchFamily="34" charset="0"/>
-                <a:ea typeface="Georgia" pitchFamily="34" charset="-122"/>
-                <a:cs typeface="Georgia" pitchFamily="34" charset="-120"/>
-              </a:rPr>
-              <a:t>Those three seats are one Letter Path. We name it so it is not a secret code.</a:t>
-            </a:r>
-            <a:endParaRPr lang="en-US" sz="1800" dirty="0"/>
+              <a:t>That is why the door asks for the username you use. The at-sign is furniture. Accents fall away so a mark from another tongue can still name a role. Anything that is not a letter becomes a letter, or it is dropped. We are here to read a face made of letters, not a form.</a:t>
+            </a:r>
+            <a:endParaRPr lang="en-US" sz="1600" dirty="0"/>
           </a:p>
         </p:txBody>
       </p:sp>
@@ -5135,7 +5300,7 @@
                 <a:ea typeface="Georgia" pitchFamily="34" charset="-122"/>
                 <a:cs typeface="Georgia" pitchFamily="34" charset="-120"/>
               </a:rPr>
-              <a:t>CC33 · letterology.club  ·  6 / 14</a:t>
+              <a:t>CC33 · letterology.club  ·  VI · XV</a:t>
             </a:r>
             <a:endParaRPr lang="en-US" sz="1100" dirty="0"/>
           </a:p>
@@ -5256,7 +5421,7 @@
                 <a:ea typeface="Georgia" pitchFamily="34" charset="-122"/>
                 <a:cs typeface="Georgia" pitchFamily="34" charset="-120"/>
               </a:rPr>
-              <a:t>WORKED EXAMPLE</a:t>
+              <a:t>THE PATH</a:t>
             </a:r>
             <a:endParaRPr lang="en-US" sz="1200" dirty="0"/>
           </a:p>
@@ -5295,7 +5460,7 @@
                 <a:ea typeface="Georgia" pitchFamily="34" charset="-122"/>
                 <a:cs typeface="Georgia" pitchFamily="34" charset="-120"/>
               </a:rPr>
-              <a:t>@lovelace</a:t>
+              <a:t>How a name becomes a reading</a:t>
             </a:r>
             <a:endParaRPr lang="en-US" sz="3200" dirty="0"/>
           </a:p>
@@ -5329,7 +5494,7 @@
               <a:buNone/>
             </a:pPr>
             <a:r>
-              <a:rPr lang="en-US" sz="1800" dirty="0">
+              <a:rPr lang="en-US" sz="1600" dirty="0">
                 <a:solidFill>
                   <a:srgbClr val="1C1712"/>
                 </a:solidFill>
@@ -5337,9 +5502,9 @@
                 <a:ea typeface="Georgia" pitchFamily="34" charset="-122"/>
                 <a:cs typeface="Georgia" pitchFamily="34" charset="-120"/>
               </a:rPr>
-              <a:t>The username lovelace letterizes as L, then E, then O.</a:t>
-            </a:r>
-            <a:endParaRPr lang="en-US" sz="1800" dirty="0"/>
+              <a:t>The first letter of the first word is how the name enters the room. That entrance is the role. A role is not a personality, and it is not a popularity contest among the letters that appear most often. It is the threshold.</a:t>
+            </a:r>
+            <a:endParaRPr lang="en-US" sz="1600" dirty="0"/>
           </a:p>
           <a:p>
             <a:pPr indent="0" marL="0">
@@ -5349,7 +5514,7 @@
               <a:buNone/>
             </a:pPr>
             <a:r>
-              <a:rPr lang="en-US" sz="1800" dirty="0">
+              <a:rPr lang="en-US" sz="1600" dirty="0">
                 <a:solidFill>
                   <a:srgbClr val="1C1712"/>
                 </a:solidFill>
@@ -5357,9 +5522,9 @@
                 <a:ea typeface="Georgia" pitchFamily="34" charset="-122"/>
                 <a:cs typeface="Georgia" pitchFamily="34" charset="-120"/>
               </a:rPr>
-              <a:t>The first letter is the Lover, which is how this name enters the room.</a:t>
-            </a:r>
-            <a:endParaRPr lang="en-US" sz="1800" dirty="0"/>
+              <a:t>After that we notice which letters keep coming back, especially at the beginning and the end of a word, because those are the places a name touches the air. The letters that keep returning tell you how this person tends to work, and what kind of place that work wants.</a:t>
+            </a:r>
+            <a:endParaRPr lang="en-US" sz="1600" dirty="0"/>
           </a:p>
           <a:p>
             <a:pPr indent="0" marL="0">
@@ -5369,7 +5534,7 @@
               <a:buNone/>
             </a:pPr>
             <a:r>
-              <a:rPr lang="en-US" sz="1800" dirty="0">
+              <a:rPr lang="en-US" sz="1600" dirty="0">
                 <a:solidFill>
                   <a:srgbClr val="1C1712"/>
                 </a:solidFill>
@@ -5377,49 +5542,9 @@
                 <a:ea typeface="Georgia" pitchFamily="34" charset="-122"/>
                 <a:cs typeface="Georgia" pitchFamily="34" charset="-120"/>
               </a:rPr>
-              <a:t>The manner is expansion, which is how the work tends to get done.</a:t>
-            </a:r>
-            <a:endParaRPr lang="en-US" sz="1800" dirty="0"/>
-          </a:p>
-          <a:p>
-            <a:pPr indent="0" marL="0">
-              <a:spcAft>
-                <a:spcPts val="1000"/>
-              </a:spcAft>
-              <a:buNone/>
-            </a:pPr>
-            <a:r>
-              <a:rPr lang="en-US" sz="1800" dirty="0">
-                <a:solidFill>
-                  <a:srgbClr val="1C1712"/>
-                </a:solidFill>
-                <a:latin typeface="Georgia" pitchFamily="34" charset="0"/>
-                <a:ea typeface="Georgia" pitchFamily="34" charset="-122"/>
-                <a:cs typeface="Georgia" pitchFamily="34" charset="-120"/>
-              </a:rPr>
-              <a:t>The field is opening, which is the kind of place that work wants.</a:t>
-            </a:r>
-            <a:endParaRPr lang="en-US" sz="1800" dirty="0"/>
-          </a:p>
-          <a:p>
-            <a:pPr indent="0" marL="0">
-              <a:spcAft>
-                <a:spcPts val="1000"/>
-              </a:spcAft>
-              <a:buNone/>
-            </a:pPr>
-            <a:r>
-              <a:rPr lang="en-US" sz="1800" dirty="0">
-                <a:solidFill>
-                  <a:srgbClr val="1C1712"/>
-                </a:solidFill>
-                <a:latin typeface="Georgia" pitchFamily="34" charset="0"/>
-                <a:ea typeface="Georgia" pitchFamily="34" charset="-122"/>
-                <a:cs typeface="Georgia" pitchFamily="34" charset="-120"/>
-              </a:rPr>
-              <a:t>The invitation from the first house is this: Give your attention to one true thing. Stop lighting every hallway.</a:t>
-            </a:r>
-            <a:endParaRPr lang="en-US" sz="1800" dirty="0"/>
+              <a:t>Together they are I Letter Path: role, how, and where. We name the path so it is not a secret code. A nameless triad is how you hide from the person you are reading.</a:t>
+            </a:r>
+            <a:endParaRPr lang="en-US" sz="1600" dirty="0"/>
           </a:p>
         </p:txBody>
       </p:sp>
@@ -5456,7 +5581,7 @@
                 <a:ea typeface="Georgia" pitchFamily="34" charset="-122"/>
                 <a:cs typeface="Georgia" pitchFamily="34" charset="-120"/>
               </a:rPr>
-              <a:t>CC33 · letterology.club  ·  7 / 14</a:t>
+              <a:t>CC33 · letterology.club  ·  VII · XV</a:t>
             </a:r>
             <a:endParaRPr lang="en-US" sz="1100" dirty="0"/>
           </a:p>
@@ -5577,7 +5702,7 @@
                 <a:ea typeface="Georgia" pitchFamily="34" charset="-122"/>
                 <a:cs typeface="Georgia" pitchFamily="34" charset="-120"/>
               </a:rPr>
-              <a:t>LUCK</a:t>
+              <a:t>WORKED EXAMPLE</a:t>
             </a:r>
             <a:endParaRPr lang="en-US" sz="1200" dirty="0"/>
           </a:p>
@@ -5616,7 +5741,7 @@
                 <a:ea typeface="Georgia" pitchFamily="34" charset="-122"/>
                 <a:cs typeface="Georgia" pitchFamily="34" charset="-120"/>
               </a:rPr>
-              <a:t>Weather, not fate</a:t>
+              <a:t>@lovelace</a:t>
             </a:r>
             <a:endParaRPr lang="en-US" sz="3200" dirty="0"/>
           </a:p>
@@ -5650,7 +5775,7 @@
               <a:buNone/>
             </a:pPr>
             <a:r>
-              <a:rPr lang="en-US" sz="1800" dirty="0">
+              <a:rPr lang="en-US" sz="1600" dirty="0">
                 <a:solidFill>
                   <a:srgbClr val="1C1712"/>
                 </a:solidFill>
@@ -5658,9 +5783,9 @@
                 <a:ea typeface="Georgia" pitchFamily="34" charset="-122"/>
                 <a:cs typeface="Georgia" pitchFamily="34" charset="-120"/>
               </a:rPr>
-              <a:t>Each date names a letter, the way the thirteenth is M.</a:t>
-            </a:r>
-            <a:endParaRPr lang="en-US" sz="1800" dirty="0"/>
+              <a:t>L. Role · how the name enters. Lover. You will not live uncommitted to beauty, body, or a beloved.</a:t>
+            </a:r>
+            <a:endParaRPr lang="en-US" sz="1600" dirty="0"/>
           </a:p>
           <a:p>
             <a:pPr indent="0" marL="0">
@@ -5670,7 +5795,7 @@
               <a:buNone/>
             </a:pPr>
             <a:r>
-              <a:rPr lang="en-US" sz="1800" dirty="0">
+              <a:rPr lang="en-US" sz="1600" dirty="0">
                 <a:solidFill>
                   <a:srgbClr val="1C1712"/>
                 </a:solidFill>
@@ -5678,9 +5803,9 @@
                 <a:ea typeface="Georgia" pitchFamily="34" charset="-122"/>
                 <a:cs typeface="Georgia" pitchFamily="34" charset="-120"/>
               </a:rPr>
-              <a:t>That letter has three helpers and three pushbacks. Together they are today’s court.</a:t>
-            </a:r>
-            <a:endParaRPr lang="en-US" sz="1800" dirty="0"/>
+              <a:t>E. How the work gets done. E is the Explorer's letter. It says there is more room than you were using.</a:t>
+            </a:r>
+            <a:endParaRPr lang="en-US" sz="1600" dirty="0"/>
           </a:p>
           <a:p>
             <a:pPr indent="0" marL="0">
@@ -5690,7 +5815,7 @@
               <a:buNone/>
             </a:pPr>
             <a:r>
-              <a:rPr lang="en-US" sz="1800" dirty="0">
+              <a:rPr lang="en-US" sz="1600" dirty="0">
                 <a:solidFill>
                   <a:srgbClr val="1C1712"/>
                 </a:solidFill>
@@ -5698,9 +5823,9 @@
                 <a:ea typeface="Georgia" pitchFamily="34" charset="-122"/>
                 <a:cs typeface="Georgia" pitchFamily="34" charset="-120"/>
               </a:rPr>
-              <a:t>Your luck today is the meeting of your path with that court.</a:t>
-            </a:r>
-            <a:endParaRPr lang="en-US" sz="1800" dirty="0"/>
+              <a:t>O. Where the work wants to happen. O is the Priestess's letter. Origin and opportunity in the same breath. A circle that does not close against the world.</a:t>
+            </a:r>
+            <a:endParaRPr lang="en-US" sz="1600" dirty="0"/>
           </a:p>
           <a:p>
             <a:pPr indent="0" marL="0">
@@ -5710,7 +5835,7 @@
               <a:buNone/>
             </a:pPr>
             <a:r>
-              <a:rPr lang="en-US" sz="1800" dirty="0">
+              <a:rPr lang="en-US" sz="1600" dirty="0">
                 <a:solidFill>
                   <a:srgbClr val="1C1712"/>
                 </a:solidFill>
@@ -5718,9 +5843,49 @@
                 <a:ea typeface="Georgia" pitchFamily="34" charset="-122"/>
                 <a:cs typeface="Georgia" pitchFamily="34" charset="-120"/>
               </a:rPr>
-              <a:t>A high number on the screen is a weather report. It is not a verdict you obey.</a:t>
-            </a:r>
-            <a:endParaRPr lang="en-US" sz="1800" dirty="0"/>
+              <a:t>The username lovelace arrives as L, then E, then O: the Lover, working by expansion, in the realm of opening.</a:t>
+            </a:r>
+            <a:endParaRPr lang="en-US" sz="1600" dirty="0"/>
+          </a:p>
+          <a:p>
+            <a:pPr indent="0" marL="0">
+              <a:spcAft>
+                <a:spcPts val="1000"/>
+              </a:spcAft>
+              <a:buNone/>
+            </a:pPr>
+            <a:r>
+              <a:rPr lang="en-US" sz="1600" dirty="0">
+                <a:solidFill>
+                  <a:srgbClr val="1C1712"/>
+                </a:solidFill>
+                <a:latin typeface="Georgia" pitchFamily="34" charset="0"/>
+                <a:ea typeface="Georgia" pitchFamily="34" charset="-122"/>
+                <a:cs typeface="Georgia" pitchFamily="34" charset="-120"/>
+              </a:rPr>
+              <a:t>The Lover is how this name enters. You will not live uncommitted to beauty, body, or a beloved.</a:t>
+            </a:r>
+            <a:endParaRPr lang="en-US" sz="1600" dirty="0"/>
+          </a:p>
+          <a:p>
+            <a:pPr indent="0" marL="0">
+              <a:spcAft>
+                <a:spcPts val="1000"/>
+              </a:spcAft>
+              <a:buNone/>
+            </a:pPr>
+            <a:r>
+              <a:rPr lang="en-US" sz="1600" dirty="0">
+                <a:solidFill>
+                  <a:srgbClr val="1C1712"/>
+                </a:solidFill>
+                <a:latin typeface="Georgia" pitchFamily="34" charset="0"/>
+                <a:ea typeface="Georgia" pitchFamily="34" charset="-122"/>
+                <a:cs typeface="Georgia" pitchFamily="34" charset="-120"/>
+              </a:rPr>
+              <a:t>Do not invent a soul to go with it. Read the path, give the invitation, and stop.</a:t>
+            </a:r>
+            <a:endParaRPr lang="en-US" sz="1600" dirty="0"/>
           </a:p>
         </p:txBody>
       </p:sp>
@@ -5757,7 +5922,7 @@
                 <a:ea typeface="Georgia" pitchFamily="34" charset="-122"/>
                 <a:cs typeface="Georgia" pitchFamily="34" charset="-120"/>
               </a:rPr>
-              <a:t>CC33 · letterology.club  ·  8 / 14</a:t>
+              <a:t>CC33 · letterology.club  ·  VIII · XV</a:t>
             </a:r>
             <a:endParaRPr lang="en-US" sz="1100" dirty="0"/>
           </a:p>
@@ -5878,7 +6043,7 @@
                 <a:ea typeface="Georgia" pitchFamily="34" charset="-122"/>
                 <a:cs typeface="Georgia" pitchFamily="34" charset="-120"/>
               </a:rPr>
-              <a:t>A DECISION</a:t>
+              <a:t>LUCK</a:t>
             </a:r>
             <a:endParaRPr lang="en-US" sz="1200" dirty="0"/>
           </a:p>
@@ -5917,7 +6082,7 @@
                 <a:ea typeface="Georgia" pitchFamily="34" charset="-122"/>
                 <a:cs typeface="Georgia" pitchFamily="34" charset="-120"/>
               </a:rPr>
-              <a:t>Letterize the act</a:t>
+              <a:t>Weather, not fate</a:t>
             </a:r>
             <a:endParaRPr lang="en-US" sz="3200" dirty="0"/>
           </a:p>
@@ -5951,7 +6116,7 @@
               <a:buNone/>
             </a:pPr>
             <a:r>
-              <a:rPr lang="en-US" sz="1800" dirty="0">
+              <a:rPr lang="en-US" sz="1600" dirty="0">
                 <a:solidFill>
                   <a:srgbClr val="1C1712"/>
                 </a:solidFill>
@@ -5959,9 +6124,9 @@
                 <a:ea typeface="Georgia" pitchFamily="34" charset="-122"/>
                 <a:cs typeface="Georgia" pitchFamily="34" charset="-120"/>
               </a:rPr>
-              <a:t>A decision is also a name. Read the act the same way you read a handle.</a:t>
-            </a:r>
-            <a:endParaRPr lang="en-US" sz="1800" dirty="0"/>
+              <a:t>A day is read the same way a name is read, so time does not get a II religion. The date names a letter, the way a username names a role. That letter keeps allies who complete its work, and pushbacks that keep it honest. Together they are today’s court.</a:t>
+            </a:r>
+            <a:endParaRPr lang="en-US" sz="1600" dirty="0"/>
           </a:p>
           <a:p>
             <a:pPr indent="0" marL="0">
@@ -5971,7 +6136,7 @@
               <a:buNone/>
             </a:pPr>
             <a:r>
-              <a:rPr lang="en-US" sz="1800" dirty="0">
+              <a:rPr lang="en-US" sz="1600" dirty="0">
                 <a:solidFill>
                   <a:srgbClr val="1C1712"/>
                 </a:solidFill>
@@ -5979,9 +6144,9 @@
                 <a:ea typeface="Georgia" pitchFamily="34" charset="-122"/>
                 <a:cs typeface="Georgia" pitchFamily="34" charset="-120"/>
               </a:rPr>
-              <a:t>Ask two questions: is this my kind of move, and is that house willing today?</a:t>
-            </a:r>
-            <a:endParaRPr lang="en-US" sz="1800" dirty="0"/>
+              <a:t>Your luck today is the meeting of your path with that court. If your usual way of working withdraws, do not force it. If today’s letter is already in the handle, the day is using something you already carry.</a:t>
+            </a:r>
+            <a:endParaRPr lang="en-US" sz="1600" dirty="0"/>
           </a:p>
           <a:p>
             <a:pPr indent="0" marL="0">
@@ -5991,7 +6156,7 @@
               <a:buNone/>
             </a:pPr>
             <a:r>
-              <a:rPr lang="en-US" sz="1800" dirty="0">
+              <a:rPr lang="en-US" sz="1600" dirty="0">
                 <a:solidFill>
                   <a:srgbClr val="1C1712"/>
                 </a:solidFill>
@@ -5999,9 +6164,9 @@
                 <a:ea typeface="Georgia" pitchFamily="34" charset="-122"/>
                 <a:cs typeface="Georgia" pitchFamily="34" charset="-120"/>
               </a:rPr>
-              <a:t>You still walk out the door.</a:t>
-            </a:r>
-            <a:endParaRPr lang="en-US" sz="1800" dirty="0"/>
+              <a:t>What the screen reports is weather. You use it to time a decision. You do not obey it.</a:t>
+            </a:r>
+            <a:endParaRPr lang="en-US" sz="1600" dirty="0"/>
           </a:p>
         </p:txBody>
       </p:sp>
@@ -6038,7 +6203,7 @@
                 <a:ea typeface="Georgia" pitchFamily="34" charset="-122"/>
                 <a:cs typeface="Georgia" pitchFamily="34" charset="-120"/>
               </a:rPr>
-              <a:t>CC33 · letterology.club  ·  9 / 14</a:t>
+              <a:t>CC33 · letterology.club  ·  IX · XV</a:t>
             </a:r>
             <a:endParaRPr lang="en-US" sz="1100" dirty="0"/>
           </a:p>

</xml_diff>